<commit_message>
Verify live prices for current lineup, add Sep 2026 launches (426 phones)
</commit_message>
<xml_diff>
--- a/SmartPrice_AI_Presentation.pptx
+++ b/SmartPrice_AI_Presentation.pptx
@@ -34808,7 +34808,7 @@
                 </a:solidFill>
                 <a:latin typeface="Segoe UI"/>
               </a:rPr>
-              <a:t>413</a:t>
+              <a:t>426</a:t>
             </a:r>
           </a:p>
         </p:txBody>
@@ -34946,7 +34946,7 @@
                 </a:solidFill>
                 <a:latin typeface="Segoe UI"/>
               </a:rPr>
-              <a:t>1,200+</a:t>
+              <a:t>1,300+</a:t>
             </a:r>
           </a:p>
         </p:txBody>
@@ -34988,7 +34988,7 @@
                 </a:solidFill>
                 <a:latin typeface="Segoe UI"/>
               </a:rPr>
-              <a:t>Store prices  (3 × per phone)</a:t>
+              <a:t>Store prices (3 × per phone)</a:t>
             </a:r>
           </a:p>
         </p:txBody>
@@ -38549,7 +38549,7 @@
                 </a:solidFill>
                 <a:latin typeface="Segoe UI"/>
               </a:rPr>
-              <a:t>Dataset  •  413 phones  •  1,200+ prices  •  seeded history</a:t>
+              <a:t>Dataset  •  426 phones  •  1,300+ prices  •  seeded history</a:t>
             </a:r>
           </a:p>
         </p:txBody>

</xml_diff>